<commit_message>
Align the deck's comparison cells with the design-intent framing
</commit_message>
<xml_diff>
--- a/presentations/signatif-intro.pptx
+++ b/presentations/signatif-intro.pptx
@@ -3971,7 +3971,7 @@
                           </a:solidFill>
                           <a:latin typeface="Calibri"/>
                         </a:rPr>
-                        <a:t>None — membership</a:t>
+                        <a:t>Out of scope — membership model</a:t>
                       </a:r>
                     </a:p>
                   </a:txBody>
@@ -4627,7 +4627,7 @@
                           </a:solidFill>
                           <a:latin typeface="Calibri"/>
                         </a:rPr>
-                        <a:t>None — append-only</a:t>
+                        <a:t>Out of scope — append-only</a:t>
                       </a:r>
                     </a:p>
                   </a:txBody>
@@ -4737,7 +4737,7 @@
                           </a:solidFill>
                           <a:latin typeface="Calibri"/>
                         </a:rPr>
-                        <a:t>Awkward, freshness-bound</a:t>
+                        <a:t>Freshness-sensitive; not the design case</a:t>
                       </a:r>
                     </a:p>
                   </a:txBody>
@@ -4764,7 +4764,7 @@
                           </a:solidFill>
                           <a:latin typeface="Calibri"/>
                         </a:rPr>
-                        <a:t>Not the model</a:t>
+                        <a:t>Not the design case</a:t>
                       </a:r>
                     </a:p>
                   </a:txBody>
@@ -4791,7 +4791,7 @@
                           </a:solidFill>
                           <a:latin typeface="Calibri"/>
                         </a:rPr>
-                        <a:t>No — needs the chain</a:t>
+                        <a:t>Requires the chain</a:t>
                       </a:r>
                     </a:p>
                   </a:txBody>
@@ -10421,7 +10421,7 @@
                 </a:solidFill>
                 <a:latin typeface="Archivo"/>
               </a:rPr>
-              <a:t>No existing standard makes artifact trust computable</a:t>
+              <a:t>No existing framework combines all of these properties</a:t>
             </a:r>
           </a:p>
         </p:txBody>

</xml_diff>

<commit_message>
Make dimension extensibility normative
The framework was designed open-closed on trust dimensions — the
co-signature block carries a generic dimension tag, the dimension-tag
registry is the extension point, and the profiles table is marked
non-exhaustive with eight dimensions already registered — but the
extension rule itself lived only in clause-6 prose. It is now a
requirement: a scheme may define additional dimensions; each is
attested by a co-signature carrying its registered tag over the same
canonical payload, verified by the same pipeline, and claimed through
a registered dimension profile, with registered dimensions not being
redefined by later profiles. A matching conformance test registers a
test dimension and verifies it flows through the standard machinery.

The registry is now 117 requirements and 117 tests across 14 classes.
</commit_message>
<xml_diff>
--- a/presentations/signatif-intro.pptx
+++ b/presentations/signatif-intro.pptx
@@ -7177,7 +7177,7 @@
                 </a:solidFill>
                 <a:latin typeface="Archivo"/>
               </a:rPr>
-              <a:t>116</a:t>
+              <a:t>117</a:t>
             </a:r>
           </a:p>
         </p:txBody>
@@ -7255,7 +7255,7 @@
                 </a:solidFill>
                 <a:latin typeface="Archivo"/>
               </a:rPr>
-              <a:t>116</a:t>
+              <a:t>117</a:t>
             </a:r>
           </a:p>
         </p:txBody>

</xml_diff>